<commit_message>
Add ecosystem-gap chapters for WebRTC, open-source core, and compliance.
Four new tracks cover SIP over WebSocket, Asterisk/FreeSWITCH/Kamailio/rtpengine, STIR/SHAKEN with the statutes this lab could open, and the glossary, sister systems, bridges, and named hooks. Counts, menus, and sources blocks follow the new rooms.

Co-authored-by: CYPHER0X9 <cipher0x9@users.noreply.github.com>
</commit_message>
<xml_diff>
--- a/downloads/sip-university-deck.pptx
+++ b/downloads/sip-university-deck.pptx
@@ -18,6 +18,10 @@
     <p:sldId id="269" r:id="rId14"/>
     <p:sldId id="270" r:id="rId15"/>
     <p:sldId id="271" r:id="rId16"/>
+    <p:sldId id="272" r:id="rId17"/>
+    <p:sldId id="273" r:id="rId18"/>
+    <p:sldId id="274" r:id="rId19"/>
+    <p:sldId id="275" r:id="rId20"/>
   </p:sldIdLst>
 </p:presentation>
 </file>
@@ -502,6 +506,186 @@
 </p:sld>
 </file>
 
+<file path=ppt/slides/slide17.xml><?xml version="1.0" encoding="utf-8"?>
+<p:sld xmlns:a="http://schemas.openxmlformats.org/drawingml/2006/main" xmlns:r="http://schemas.openxmlformats.org/officeDocument/2006/relationships" xmlns:p="http://schemas.openxmlformats.org/presentationml/2006/main">
+  <p:cSld>
+    <p:spTree>
+      <p:nvGrpSpPr>
+        <p:cNvPr id="1" name=""/>
+        <p:cNvGrpSpPr/>
+        <p:nvPr/>
+      </p:nvGrpSpPr>
+      <p:grpSpPr/>
+      <p:sp>
+        <p:nvSpPr>
+          <p:cNvPr id="2" name="Title"/>
+          <p:cNvSpPr/>
+          <p:nvPr/>
+        </p:nvSpPr>
+        <p:spPr/>
+        <p:txBody>
+          <a:bodyPr/>
+          <a:lstStyle/>
+          <a:p>
+            <a:r>
+              <a:rPr lang="en-US" sz="1600"/>
+              <a:t>SIP Universe</a:t>
+            </a:r>
+          </a:p>
+          <a:p>
+            <a:r>
+              <a:rPr lang="en-US" sz="2800"/>
+              <a:t>WebRTC and SIP over WebSocket</a:t>
+            </a:r>
+          </a:p>
+          <a:p>
+            <a:r>
+              <a:rPr lang="en-US" sz="1600"/>
+              <a:t>How a browser reaches SIP: RFC 7118 on the signaling socket, ICE for candidates, and DTLS-SRTP for the media.</a:t>
+            </a:r>
+          </a:p>
+          <a:p>
+            <a:r>
+              <a:rPr lang="en-US" sz="1600"/>
+              <a:t>Study label. Confirm vendor pages.</a:t>
+            </a:r>
+          </a:p>
+          <a:p>
+            <a:r>
+              <a:rPr lang="en-US" sz="1600"/>
+              <a:t>© 2026 CypherMonkeyLabs</a:t>
+            </a:r>
+          </a:p>
+        </p:txBody>
+      </p:sp>
+    </p:spTree>
+  </p:cSld>
+  <p:clrMapOvr>
+    <a:masterClrMapping/>
+  </p:clrMapOvr>
+</p:sld>
+</file>
+
+<file path=ppt/slides/slide18.xml><?xml version="1.0" encoding="utf-8"?>
+<p:sld xmlns:a="http://schemas.openxmlformats.org/drawingml/2006/main" xmlns:r="http://schemas.openxmlformats.org/officeDocument/2006/relationships" xmlns:p="http://schemas.openxmlformats.org/presentationml/2006/main">
+  <p:cSld>
+    <p:spTree>
+      <p:nvGrpSpPr>
+        <p:cNvPr id="1" name=""/>
+        <p:cNvGrpSpPr/>
+        <p:nvPr/>
+      </p:nvGrpSpPr>
+      <p:grpSpPr/>
+      <p:sp>
+        <p:nvSpPr>
+          <p:cNvPr id="2" name="Title"/>
+          <p:cNvSpPr/>
+          <p:nvPr/>
+        </p:nvSpPr>
+        <p:spPr/>
+        <p:txBody>
+          <a:bodyPr/>
+          <a:lstStyle/>
+          <a:p>
+            <a:r>
+              <a:rPr lang="en-US" sz="1600"/>
+              <a:t>SIP Universe</a:t>
+            </a:r>
+          </a:p>
+          <a:p>
+            <a:r>
+              <a:rPr lang="en-US" sz="2800"/>
+              <a:t>Open-source telephony core</a:t>
+            </a:r>
+          </a:p>
+          <a:p>
+            <a:r>
+              <a:rPr lang="en-US" sz="1600"/>
+              <a:t>Asterisk, FreeSWITCH, Kamailio, and rtpengine do different jobs. The pages below say which job each project claims.</a:t>
+            </a:r>
+          </a:p>
+          <a:p>
+            <a:r>
+              <a:rPr lang="en-US" sz="1600"/>
+              <a:t>Study label. Confirm vendor pages.</a:t>
+            </a:r>
+          </a:p>
+          <a:p>
+            <a:r>
+              <a:rPr lang="en-US" sz="1600"/>
+              <a:t>© 2026 CypherMonkeyLabs</a:t>
+            </a:r>
+          </a:p>
+        </p:txBody>
+      </p:sp>
+    </p:spTree>
+  </p:cSld>
+  <p:clrMapOvr>
+    <a:masterClrMapping/>
+  </p:clrMapOvr>
+</p:sld>
+</file>
+
+<file path=ppt/slides/slide19.xml><?xml version="1.0" encoding="utf-8"?>
+<p:sld xmlns:a="http://schemas.openxmlformats.org/drawingml/2006/main" xmlns:r="http://schemas.openxmlformats.org/officeDocument/2006/relationships" xmlns:p="http://schemas.openxmlformats.org/presentationml/2006/main">
+  <p:cSld>
+    <p:spTree>
+      <p:nvGrpSpPr>
+        <p:cNvPr id="1" name=""/>
+        <p:cNvGrpSpPr/>
+        <p:nvPr/>
+      </p:nvGrpSpPr>
+      <p:grpSpPr/>
+      <p:sp>
+        <p:nvSpPr>
+          <p:cNvPr id="2" name="Title"/>
+          <p:cNvSpPr/>
+          <p:nvPr/>
+        </p:nvSpPr>
+        <p:spPr/>
+        <p:txBody>
+          <a:bodyPr/>
+          <a:lstStyle/>
+          <a:p>
+            <a:r>
+              <a:rPr lang="en-US" sz="1600"/>
+              <a:t>SIP Universe</a:t>
+            </a:r>
+          </a:p>
+          <a:p>
+            <a:r>
+              <a:rPr lang="en-US" sz="2800"/>
+              <a:t>Call authentication and compliance</a:t>
+            </a:r>
+          </a:p>
+          <a:p>
+            <a:r>
+              <a:rPr lang="en-US" sz="1600"/>
+              <a:t>STIR/SHAKEN, Kari's Law, RAY BAUM'S Act, and 10DLC, as the opened documents describe them. Educational only. Not legal advice.</a:t>
+            </a:r>
+          </a:p>
+          <a:p>
+            <a:r>
+              <a:rPr lang="en-US" sz="1600"/>
+              <a:t>Study label. Confirm vendor pages.</a:t>
+            </a:r>
+          </a:p>
+          <a:p>
+            <a:r>
+              <a:rPr lang="en-US" sz="1600"/>
+              <a:t>© 2026 CypherMonkeyLabs</a:t>
+            </a:r>
+          </a:p>
+        </p:txBody>
+      </p:sp>
+    </p:spTree>
+  </p:cSld>
+  <p:clrMapOvr>
+    <a:masterClrMapping/>
+  </p:clrMapOvr>
+</p:sld>
+</file>
+
 <file path=ppt/slides/slide2.xml><?xml version="1.0" encoding="utf-8"?>
 <p:sld xmlns:a="http://schemas.openxmlformats.org/drawingml/2006/main" xmlns:r="http://schemas.openxmlformats.org/officeDocument/2006/relationships" xmlns:p="http://schemas.openxmlformats.org/presentationml/2006/main">
   <p:cSld>
@@ -562,6 +746,66 @@
 </p:sld>
 </file>
 
+<file path=ppt/slides/slide20.xml><?xml version="1.0" encoding="utf-8"?>
+<p:sld xmlns:a="http://schemas.openxmlformats.org/drawingml/2006/main" xmlns:r="http://schemas.openxmlformats.org/officeDocument/2006/relationships" xmlns:p="http://schemas.openxmlformats.org/presentationml/2006/main">
+  <p:cSld>
+    <p:spTree>
+      <p:nvGrpSpPr>
+        <p:cNvPr id="1" name=""/>
+        <p:cNvGrpSpPr/>
+        <p:nvPr/>
+      </p:nvGrpSpPr>
+      <p:grpSpPr/>
+      <p:sp>
+        <p:nvSpPr>
+          <p:cNvPr id="2" name="Title"/>
+          <p:cNvSpPr/>
+          <p:nvPr/>
+        </p:nvSpPr>
+        <p:spPr/>
+        <p:txBody>
+          <a:bodyPr/>
+          <a:lstStyle/>
+          <a:p>
+            <a:r>
+              <a:rPr lang="en-US" sz="1600"/>
+              <a:t>SIP Universe</a:t>
+            </a:r>
+          </a:p>
+          <a:p>
+            <a:r>
+              <a:rPr lang="en-US" sz="2800"/>
+              <a:t>Ecosystem, maps, and integration hooks</a:t>
+            </a:r>
+          </a:p>
+          <a:p>
+            <a:r>
+              <a:rPr lang="en-US" sz="1600"/>
+              <a:t>Glossary, sister systems, configuration, bridges from enterprise UC to the open projects, and the hooks those projects actually name.</a:t>
+            </a:r>
+          </a:p>
+          <a:p>
+            <a:r>
+              <a:rPr lang="en-US" sz="1600"/>
+              <a:t>Study label. Confirm vendor pages.</a:t>
+            </a:r>
+          </a:p>
+          <a:p>
+            <a:r>
+              <a:rPr lang="en-US" sz="1600"/>
+              <a:t>© 2026 CypherMonkeyLabs</a:t>
+            </a:r>
+          </a:p>
+        </p:txBody>
+      </p:sp>
+    </p:spTree>
+  </p:cSld>
+  <p:clrMapOvr>
+    <a:masterClrMapping/>
+  </p:clrMapOvr>
+</p:sld>
+</file>
+
 <file path=ppt/slides/slide3.xml><?xml version="1.0" encoding="utf-8"?>
 <p:sld xmlns:a="http://schemas.openxmlformats.org/drawingml/2006/main" xmlns:r="http://schemas.openxmlformats.org/officeDocument/2006/relationships" xmlns:p="http://schemas.openxmlformats.org/presentationml/2006/main">
   <p:cSld>

</xml_diff>